<commit_message>
feat(sih_presentation): match exact 1:1 structure and layout of official SIH 2026 idea presentation template
</commit_message>
<xml_diff>
--- a/sih_presentation/SIH_Hackastra_Exact_Submission.pptx
+++ b/sih_presentation/SIH_Hackastra_Exact_Submission.pptx
@@ -3508,51 +3508,32 @@
       </p:sp>
       <p:sp>
         <p:nvSpPr>
-          <p:cNvPr id="3" name="Rounded Rectangle 2"/>
-          <p:cNvSpPr/>
+          <p:cNvPr id="3" name="TextBox 2"/>
+          <p:cNvSpPr txBox="1"/>
           <p:nvPr/>
         </p:nvSpPr>
         <p:spPr>
           <a:xfrm>
-            <a:off x="3291840" y="164592"/>
-            <a:ext cx="5577840" cy="685800"/>
+            <a:off x="2286000" y="164592"/>
+            <a:ext cx="7619695" cy="685800"/>
           </a:xfrm>
-          <a:prstGeom prst="roundRect">
+          <a:prstGeom prst="rect">
             <a:avLst/>
           </a:prstGeom>
-          <a:solidFill>
-            <a:srgbClr val="FFFFFF"/>
-          </a:solidFill>
-          <a:ln w="19050">
-            <a:solidFill>
-              <a:srgbClr val="000000"/>
-            </a:solidFill>
-          </a:ln>
+          <a:noFill/>
         </p:spPr>
-        <p:style>
-          <a:lnRef idx="1">
-            <a:schemeClr val="accent1"/>
-          </a:lnRef>
-          <a:fillRef idx="3">
-            <a:schemeClr val="accent1"/>
-          </a:fillRef>
-          <a:effectRef idx="2">
-            <a:schemeClr val="accent1"/>
-          </a:effectRef>
-          <a:fontRef idx="minor">
-            <a:schemeClr val="lt1"/>
-          </a:fontRef>
-        </p:style>
-        <p:txBody>
-          <a:bodyPr rtlCol="0" anchor="ctr" wrap="square"/>
+        <p:txBody>
+          <a:bodyPr wrap="square">
+            <a:spAutoFit/>
+          </a:bodyPr>
           <a:lstStyle/>
           <a:p>
             <a:pPr algn="ctr">
-              <a:defRPr sz="2400" b="1">
-                <a:solidFill>
-                  <a:srgbClr val="000000"/>
-                </a:solidFill>
-                <a:latin typeface="Arial"/>
+              <a:defRPr sz="2600" b="1">
+                <a:solidFill>
+                  <a:srgbClr val="000000"/>
+                </a:solidFill>
+                <a:latin typeface="Times New Roman"/>
               </a:defRPr>
             </a:pPr>
             <a:r>
@@ -3587,14 +3568,67 @@
       </p:pic>
       <p:sp>
         <p:nvSpPr>
-          <p:cNvPr id="5" name="TextBox 4"/>
+          <p:cNvPr id="5" name="Rectangle 4"/>
+          <p:cNvSpPr/>
+          <p:nvPr/>
+        </p:nvSpPr>
+        <p:spPr>
+          <a:xfrm>
+            <a:off x="0" y="6510528"/>
+            <a:ext cx="12191695" cy="347472"/>
+          </a:xfrm>
+          <a:prstGeom prst="rect">
+            <a:avLst/>
+          </a:prstGeom>
+          <a:solidFill>
+            <a:srgbClr val="0070C0"/>
+          </a:solidFill>
+          <a:ln>
+            <a:noFill/>
+          </a:ln>
+        </p:spPr>
+        <p:style>
+          <a:lnRef idx="1">
+            <a:schemeClr val="accent1"/>
+          </a:lnRef>
+          <a:fillRef idx="3">
+            <a:schemeClr val="accent1"/>
+          </a:fillRef>
+          <a:effectRef idx="2">
+            <a:schemeClr val="accent1"/>
+          </a:effectRef>
+          <a:fontRef idx="minor">
+            <a:schemeClr val="lt1"/>
+          </a:fontRef>
+        </p:style>
+        <p:txBody>
+          <a:bodyPr rtlCol="0" anchor="ctr" wrap="none"/>
+          <a:lstStyle/>
+          <a:p>
+            <a:pPr algn="ctr">
+              <a:defRPr sz="1200" b="1">
+                <a:solidFill>
+                  <a:srgbClr val="FFFFFF"/>
+                </a:solidFill>
+                <a:latin typeface="Arial"/>
+              </a:defRPr>
+            </a:pPr>
+            <a:r>
+              <a:t>@SIH Idea submission- Template</a:t>
+            </a:r>
+          </a:p>
+        </p:txBody>
+      </p:sp>
+      <p:sp>
+        <p:nvSpPr>
+          <p:cNvPr id="6" name="TextBox 5"/>
           <p:cNvSpPr txBox="1"/>
           <p:nvPr/>
         </p:nvSpPr>
         <p:spPr>
           <a:xfrm>
-            <a:off x="11338560" y="6327648"/>
-            <a:ext cx="548640" cy="365760"/>
+            <a:off x="10972800" y="6510528"/>
+            <a:ext cx="1005840" cy="347472"/>
           </a:xfrm>
           <a:prstGeom prst="rect">
             <a:avLst/>
@@ -3608,9 +3642,9 @@
           <a:lstStyle/>
           <a:p>
             <a:pPr algn="r">
-              <a:defRPr sz="1400" b="1">
-                <a:solidFill>
-                  <a:srgbClr val="000000"/>
+              <a:defRPr sz="1300" b="1">
+                <a:solidFill>
+                  <a:srgbClr val="FFFFFF"/>
                 </a:solidFill>
                 <a:latin typeface="Arial"/>
               </a:defRPr>
@@ -3623,7 +3657,7 @@
       </p:sp>
       <p:sp>
         <p:nvSpPr>
-          <p:cNvPr id="6" name="Rectangle 5"/>
+          <p:cNvPr id="7" name="Rectangle 6"/>
           <p:cNvSpPr/>
           <p:nvPr/>
         </p:nvSpPr>
@@ -3668,7 +3702,7 @@
       </p:sp>
       <p:sp>
         <p:nvSpPr>
-          <p:cNvPr id="7" name="TextBox 6"/>
+          <p:cNvPr id="8" name="TextBox 7"/>
           <p:cNvSpPr txBox="1"/>
           <p:nvPr/>
         </p:nvSpPr>
@@ -3941,7 +3975,7 @@
       </p:sp>
       <p:sp>
         <p:nvSpPr>
-          <p:cNvPr id="8" name="Rectangle 7"/>
+          <p:cNvPr id="9" name="Rectangle 8"/>
           <p:cNvSpPr/>
           <p:nvPr/>
         </p:nvSpPr>
@@ -3986,7 +4020,7 @@
       </p:sp>
       <p:pic>
         <p:nvPicPr>
-          <p:cNvPr id="9" name="Picture 8" descr="hackastra_flowchart.png"/>
+          <p:cNvPr id="10" name="Picture 9" descr="hackastra_flowchart.png"/>
           <p:cNvPicPr>
             <a:picLocks noChangeAspect="1"/>
           </p:cNvPicPr>
@@ -4096,51 +4130,32 @@
       </p:sp>
       <p:sp>
         <p:nvSpPr>
-          <p:cNvPr id="3" name="Rounded Rectangle 2"/>
-          <p:cNvSpPr/>
+          <p:cNvPr id="3" name="TextBox 2"/>
+          <p:cNvSpPr txBox="1"/>
           <p:nvPr/>
         </p:nvSpPr>
         <p:spPr>
           <a:xfrm>
-            <a:off x="3291840" y="164592"/>
-            <a:ext cx="5577840" cy="685800"/>
+            <a:off x="2286000" y="164592"/>
+            <a:ext cx="7619695" cy="685800"/>
           </a:xfrm>
-          <a:prstGeom prst="roundRect">
+          <a:prstGeom prst="rect">
             <a:avLst/>
           </a:prstGeom>
-          <a:solidFill>
-            <a:srgbClr val="FFFFFF"/>
-          </a:solidFill>
-          <a:ln w="19050">
-            <a:solidFill>
-              <a:srgbClr val="000000"/>
-            </a:solidFill>
-          </a:ln>
+          <a:noFill/>
         </p:spPr>
-        <p:style>
-          <a:lnRef idx="1">
-            <a:schemeClr val="accent1"/>
-          </a:lnRef>
-          <a:fillRef idx="3">
-            <a:schemeClr val="accent1"/>
-          </a:fillRef>
-          <a:effectRef idx="2">
-            <a:schemeClr val="accent1"/>
-          </a:effectRef>
-          <a:fontRef idx="minor">
-            <a:schemeClr val="lt1"/>
-          </a:fontRef>
-        </p:style>
-        <p:txBody>
-          <a:bodyPr rtlCol="0" anchor="ctr" wrap="square"/>
+        <p:txBody>
+          <a:bodyPr wrap="square">
+            <a:spAutoFit/>
+          </a:bodyPr>
           <a:lstStyle/>
           <a:p>
             <a:pPr algn="ctr">
-              <a:defRPr sz="2400" b="1">
-                <a:solidFill>
-                  <a:srgbClr val="000000"/>
-                </a:solidFill>
-                <a:latin typeface="Arial"/>
+              <a:defRPr sz="2600" b="1">
+                <a:solidFill>
+                  <a:srgbClr val="000000"/>
+                </a:solidFill>
+                <a:latin typeface="Times New Roman"/>
               </a:defRPr>
             </a:pPr>
             <a:r>
@@ -4175,14 +4190,67 @@
       </p:pic>
       <p:sp>
         <p:nvSpPr>
-          <p:cNvPr id="5" name="TextBox 4"/>
+          <p:cNvPr id="5" name="Rectangle 4"/>
+          <p:cNvSpPr/>
+          <p:nvPr/>
+        </p:nvSpPr>
+        <p:spPr>
+          <a:xfrm>
+            <a:off x="0" y="6510528"/>
+            <a:ext cx="12191695" cy="347472"/>
+          </a:xfrm>
+          <a:prstGeom prst="rect">
+            <a:avLst/>
+          </a:prstGeom>
+          <a:solidFill>
+            <a:srgbClr val="0070C0"/>
+          </a:solidFill>
+          <a:ln>
+            <a:noFill/>
+          </a:ln>
+        </p:spPr>
+        <p:style>
+          <a:lnRef idx="1">
+            <a:schemeClr val="accent1"/>
+          </a:lnRef>
+          <a:fillRef idx="3">
+            <a:schemeClr val="accent1"/>
+          </a:fillRef>
+          <a:effectRef idx="2">
+            <a:schemeClr val="accent1"/>
+          </a:effectRef>
+          <a:fontRef idx="minor">
+            <a:schemeClr val="lt1"/>
+          </a:fontRef>
+        </p:style>
+        <p:txBody>
+          <a:bodyPr rtlCol="0" anchor="ctr" wrap="none"/>
+          <a:lstStyle/>
+          <a:p>
+            <a:pPr algn="ctr">
+              <a:defRPr sz="1200" b="1">
+                <a:solidFill>
+                  <a:srgbClr val="FFFFFF"/>
+                </a:solidFill>
+                <a:latin typeface="Arial"/>
+              </a:defRPr>
+            </a:pPr>
+            <a:r>
+              <a:t>@SIH Idea submission- Template</a:t>
+            </a:r>
+          </a:p>
+        </p:txBody>
+      </p:sp>
+      <p:sp>
+        <p:nvSpPr>
+          <p:cNvPr id="6" name="TextBox 5"/>
           <p:cNvSpPr txBox="1"/>
           <p:nvPr/>
         </p:nvSpPr>
         <p:spPr>
           <a:xfrm>
-            <a:off x="11338560" y="6327648"/>
-            <a:ext cx="548640" cy="365760"/>
+            <a:off x="10972800" y="6510528"/>
+            <a:ext cx="1005840" cy="347472"/>
           </a:xfrm>
           <a:prstGeom prst="rect">
             <a:avLst/>
@@ -4196,9 +4264,9 @@
           <a:lstStyle/>
           <a:p>
             <a:pPr algn="r">
-              <a:defRPr sz="1400" b="1">
-                <a:solidFill>
-                  <a:srgbClr val="000000"/>
+              <a:defRPr sz="1300" b="1">
+                <a:solidFill>
+                  <a:srgbClr val="FFFFFF"/>
                 </a:solidFill>
                 <a:latin typeface="Arial"/>
               </a:defRPr>
@@ -4211,7 +4279,7 @@
       </p:sp>
       <p:sp>
         <p:nvSpPr>
-          <p:cNvPr id="6" name="Rectangle 5"/>
+          <p:cNvPr id="7" name="Rectangle 6"/>
           <p:cNvSpPr/>
           <p:nvPr/>
         </p:nvSpPr>
@@ -4256,7 +4324,7 @@
       </p:sp>
       <p:sp>
         <p:nvSpPr>
-          <p:cNvPr id="7" name="TextBox 6"/>
+          <p:cNvPr id="8" name="TextBox 7"/>
           <p:cNvSpPr txBox="1"/>
           <p:nvPr/>
         </p:nvSpPr>
@@ -4529,7 +4597,7 @@
       </p:sp>
       <p:sp>
         <p:nvSpPr>
-          <p:cNvPr id="8" name="Rectangle 7"/>
+          <p:cNvPr id="9" name="Rectangle 8"/>
           <p:cNvSpPr/>
           <p:nvPr/>
         </p:nvSpPr>
@@ -4574,7 +4642,7 @@
       </p:sp>
       <p:pic>
         <p:nvPicPr>
-          <p:cNvPr id="9" name="Picture 8" descr="fra_setu_ui.png"/>
+          <p:cNvPr id="10" name="Picture 9" descr="fra_setu_ui.png"/>
           <p:cNvPicPr>
             <a:picLocks noChangeAspect="1"/>
           </p:cNvPicPr>
@@ -4598,7 +4666,7 @@
       </p:pic>
       <p:sp>
         <p:nvSpPr>
-          <p:cNvPr id="10" name="TextBox 9"/>
+          <p:cNvPr id="11" name="TextBox 10"/>
           <p:cNvSpPr txBox="1"/>
           <p:nvPr/>
         </p:nvSpPr>
@@ -4634,7 +4702,7 @@
       </p:sp>
       <p:sp>
         <p:nvSpPr>
-          <p:cNvPr id="11" name="Rectangle 10"/>
+          <p:cNvPr id="12" name="Rectangle 11"/>
           <p:cNvSpPr/>
           <p:nvPr/>
         </p:nvSpPr>
@@ -4679,7 +4747,7 @@
       </p:sp>
       <p:pic>
         <p:nvPicPr>
-          <p:cNvPr id="12" name="Picture 11" descr="hackastra_arch.png"/>
+          <p:cNvPr id="13" name="Picture 12" descr="hackastra_arch.png"/>
           <p:cNvPicPr>
             <a:picLocks noChangeAspect="1"/>
           </p:cNvPicPr>
@@ -4789,51 +4857,32 @@
       </p:sp>
       <p:sp>
         <p:nvSpPr>
-          <p:cNvPr id="3" name="Rounded Rectangle 2"/>
-          <p:cNvSpPr/>
+          <p:cNvPr id="3" name="TextBox 2"/>
+          <p:cNvSpPr txBox="1"/>
           <p:nvPr/>
         </p:nvSpPr>
         <p:spPr>
           <a:xfrm>
-            <a:off x="3291840" y="164592"/>
-            <a:ext cx="5577840" cy="685800"/>
+            <a:off x="2286000" y="164592"/>
+            <a:ext cx="7619695" cy="685800"/>
           </a:xfrm>
-          <a:prstGeom prst="roundRect">
+          <a:prstGeom prst="rect">
             <a:avLst/>
           </a:prstGeom>
-          <a:solidFill>
-            <a:srgbClr val="FFFFFF"/>
-          </a:solidFill>
-          <a:ln w="19050">
-            <a:solidFill>
-              <a:srgbClr val="000000"/>
-            </a:solidFill>
-          </a:ln>
+          <a:noFill/>
         </p:spPr>
-        <p:style>
-          <a:lnRef idx="1">
-            <a:schemeClr val="accent1"/>
-          </a:lnRef>
-          <a:fillRef idx="3">
-            <a:schemeClr val="accent1"/>
-          </a:fillRef>
-          <a:effectRef idx="2">
-            <a:schemeClr val="accent1"/>
-          </a:effectRef>
-          <a:fontRef idx="minor">
-            <a:schemeClr val="lt1"/>
-          </a:fontRef>
-        </p:style>
-        <p:txBody>
-          <a:bodyPr rtlCol="0" anchor="ctr" wrap="square"/>
+        <p:txBody>
+          <a:bodyPr wrap="square">
+            <a:spAutoFit/>
+          </a:bodyPr>
           <a:lstStyle/>
           <a:p>
             <a:pPr algn="ctr">
-              <a:defRPr sz="2200" b="1">
-                <a:solidFill>
-                  <a:srgbClr val="000000"/>
-                </a:solidFill>
-                <a:latin typeface="Arial"/>
+              <a:defRPr sz="2400" b="1">
+                <a:solidFill>
+                  <a:srgbClr val="000000"/>
+                </a:solidFill>
+                <a:latin typeface="Times New Roman"/>
               </a:defRPr>
             </a:pPr>
             <a:r>
@@ -4868,14 +4917,67 @@
       </p:pic>
       <p:sp>
         <p:nvSpPr>
-          <p:cNvPr id="5" name="TextBox 4"/>
+          <p:cNvPr id="5" name="Rectangle 4"/>
+          <p:cNvSpPr/>
+          <p:nvPr/>
+        </p:nvSpPr>
+        <p:spPr>
+          <a:xfrm>
+            <a:off x="0" y="6510528"/>
+            <a:ext cx="12191695" cy="347472"/>
+          </a:xfrm>
+          <a:prstGeom prst="rect">
+            <a:avLst/>
+          </a:prstGeom>
+          <a:solidFill>
+            <a:srgbClr val="0070C0"/>
+          </a:solidFill>
+          <a:ln>
+            <a:noFill/>
+          </a:ln>
+        </p:spPr>
+        <p:style>
+          <a:lnRef idx="1">
+            <a:schemeClr val="accent1"/>
+          </a:lnRef>
+          <a:fillRef idx="3">
+            <a:schemeClr val="accent1"/>
+          </a:fillRef>
+          <a:effectRef idx="2">
+            <a:schemeClr val="accent1"/>
+          </a:effectRef>
+          <a:fontRef idx="minor">
+            <a:schemeClr val="lt1"/>
+          </a:fontRef>
+        </p:style>
+        <p:txBody>
+          <a:bodyPr rtlCol="0" anchor="ctr" wrap="none"/>
+          <a:lstStyle/>
+          <a:p>
+            <a:pPr algn="ctr">
+              <a:defRPr sz="1200" b="1">
+                <a:solidFill>
+                  <a:srgbClr val="FFFFFF"/>
+                </a:solidFill>
+                <a:latin typeface="Arial"/>
+              </a:defRPr>
+            </a:pPr>
+            <a:r>
+              <a:t>@SIH Idea submission- Template</a:t>
+            </a:r>
+          </a:p>
+        </p:txBody>
+      </p:sp>
+      <p:sp>
+        <p:nvSpPr>
+          <p:cNvPr id="6" name="TextBox 5"/>
           <p:cNvSpPr txBox="1"/>
           <p:nvPr/>
         </p:nvSpPr>
         <p:spPr>
           <a:xfrm>
-            <a:off x="11338560" y="6327648"/>
-            <a:ext cx="548640" cy="365760"/>
+            <a:off x="10972800" y="6510528"/>
+            <a:ext cx="1005840" cy="347472"/>
           </a:xfrm>
           <a:prstGeom prst="rect">
             <a:avLst/>
@@ -4889,9 +4991,9 @@
           <a:lstStyle/>
           <a:p>
             <a:pPr algn="r">
-              <a:defRPr sz="1400" b="1">
-                <a:solidFill>
-                  <a:srgbClr val="000000"/>
+              <a:defRPr sz="1300" b="1">
+                <a:solidFill>
+                  <a:srgbClr val="FFFFFF"/>
                 </a:solidFill>
                 <a:latin typeface="Arial"/>
               </a:defRPr>
@@ -4904,7 +5006,7 @@
       </p:sp>
       <p:sp>
         <p:nvSpPr>
-          <p:cNvPr id="6" name="Rectangle 5"/>
+          <p:cNvPr id="7" name="Rectangle 6"/>
           <p:cNvSpPr/>
           <p:nvPr/>
         </p:nvSpPr>
@@ -4949,7 +5051,7 @@
       </p:sp>
       <p:sp>
         <p:nvSpPr>
-          <p:cNvPr id="7" name="TextBox 6"/>
+          <p:cNvPr id="8" name="TextBox 7"/>
           <p:cNvSpPr txBox="1"/>
           <p:nvPr/>
         </p:nvSpPr>
@@ -5324,7 +5426,7 @@
       </p:sp>
       <p:sp>
         <p:nvSpPr>
-          <p:cNvPr id="8" name="Rectangle 7"/>
+          <p:cNvPr id="9" name="Rectangle 8"/>
           <p:cNvSpPr/>
           <p:nvPr/>
         </p:nvSpPr>
@@ -5369,7 +5471,7 @@
       </p:sp>
       <p:sp>
         <p:nvSpPr>
-          <p:cNvPr id="9" name="TextBox 8"/>
+          <p:cNvPr id="10" name="TextBox 9"/>
           <p:cNvSpPr txBox="1"/>
           <p:nvPr/>
         </p:nvSpPr>
@@ -5830,51 +5932,32 @@
       </p:sp>
       <p:sp>
         <p:nvSpPr>
-          <p:cNvPr id="3" name="Rounded Rectangle 2"/>
-          <p:cNvSpPr/>
+          <p:cNvPr id="3" name="TextBox 2"/>
+          <p:cNvSpPr txBox="1"/>
           <p:nvPr/>
         </p:nvSpPr>
         <p:spPr>
           <a:xfrm>
-            <a:off x="3291840" y="164592"/>
-            <a:ext cx="5577840" cy="685800"/>
+            <a:off x="2286000" y="164592"/>
+            <a:ext cx="7619695" cy="685800"/>
           </a:xfrm>
-          <a:prstGeom prst="roundRect">
+          <a:prstGeom prst="rect">
             <a:avLst/>
           </a:prstGeom>
-          <a:solidFill>
-            <a:srgbClr val="FFFFFF"/>
-          </a:solidFill>
-          <a:ln w="19050">
-            <a:solidFill>
-              <a:srgbClr val="000000"/>
-            </a:solidFill>
-          </a:ln>
+          <a:noFill/>
         </p:spPr>
-        <p:style>
-          <a:lnRef idx="1">
-            <a:schemeClr val="accent1"/>
-          </a:lnRef>
-          <a:fillRef idx="3">
-            <a:schemeClr val="accent1"/>
-          </a:fillRef>
-          <a:effectRef idx="2">
-            <a:schemeClr val="accent1"/>
-          </a:effectRef>
-          <a:fontRef idx="minor">
-            <a:schemeClr val="lt1"/>
-          </a:fontRef>
-        </p:style>
-        <p:txBody>
-          <a:bodyPr rtlCol="0" anchor="ctr" wrap="square"/>
+        <p:txBody>
+          <a:bodyPr wrap="square">
+            <a:spAutoFit/>
+          </a:bodyPr>
           <a:lstStyle/>
           <a:p>
             <a:pPr algn="ctr">
-              <a:defRPr sz="2400" b="1">
-                <a:solidFill>
-                  <a:srgbClr val="000000"/>
-                </a:solidFill>
-                <a:latin typeface="Arial"/>
+              <a:defRPr sz="2600" b="1">
+                <a:solidFill>
+                  <a:srgbClr val="000000"/>
+                </a:solidFill>
+                <a:latin typeface="Times New Roman"/>
               </a:defRPr>
             </a:pPr>
             <a:r>
@@ -5909,14 +5992,67 @@
       </p:pic>
       <p:sp>
         <p:nvSpPr>
-          <p:cNvPr id="5" name="TextBox 4"/>
+          <p:cNvPr id="5" name="Rectangle 4"/>
+          <p:cNvSpPr/>
+          <p:nvPr/>
+        </p:nvSpPr>
+        <p:spPr>
+          <a:xfrm>
+            <a:off x="0" y="6510528"/>
+            <a:ext cx="12191695" cy="347472"/>
+          </a:xfrm>
+          <a:prstGeom prst="rect">
+            <a:avLst/>
+          </a:prstGeom>
+          <a:solidFill>
+            <a:srgbClr val="0070C0"/>
+          </a:solidFill>
+          <a:ln>
+            <a:noFill/>
+          </a:ln>
+        </p:spPr>
+        <p:style>
+          <a:lnRef idx="1">
+            <a:schemeClr val="accent1"/>
+          </a:lnRef>
+          <a:fillRef idx="3">
+            <a:schemeClr val="accent1"/>
+          </a:fillRef>
+          <a:effectRef idx="2">
+            <a:schemeClr val="accent1"/>
+          </a:effectRef>
+          <a:fontRef idx="minor">
+            <a:schemeClr val="lt1"/>
+          </a:fontRef>
+        </p:style>
+        <p:txBody>
+          <a:bodyPr rtlCol="0" anchor="ctr" wrap="none"/>
+          <a:lstStyle/>
+          <a:p>
+            <a:pPr algn="ctr">
+              <a:defRPr sz="1200" b="1">
+                <a:solidFill>
+                  <a:srgbClr val="FFFFFF"/>
+                </a:solidFill>
+                <a:latin typeface="Arial"/>
+              </a:defRPr>
+            </a:pPr>
+            <a:r>
+              <a:t>@SIH Idea submission- Template</a:t>
+            </a:r>
+          </a:p>
+        </p:txBody>
+      </p:sp>
+      <p:sp>
+        <p:nvSpPr>
+          <p:cNvPr id="6" name="TextBox 5"/>
           <p:cNvSpPr txBox="1"/>
           <p:nvPr/>
         </p:nvSpPr>
         <p:spPr>
           <a:xfrm>
-            <a:off x="11338560" y="6327648"/>
-            <a:ext cx="548640" cy="365760"/>
+            <a:off x="10972800" y="6510528"/>
+            <a:ext cx="1005840" cy="347472"/>
           </a:xfrm>
           <a:prstGeom prst="rect">
             <a:avLst/>
@@ -5930,9 +6066,9 @@
           <a:lstStyle/>
           <a:p>
             <a:pPr algn="r">
-              <a:defRPr sz="1400" b="1">
-                <a:solidFill>
-                  <a:srgbClr val="000000"/>
+              <a:defRPr sz="1300" b="1">
+                <a:solidFill>
+                  <a:srgbClr val="FFFFFF"/>
                 </a:solidFill>
                 <a:latin typeface="Arial"/>
               </a:defRPr>
@@ -5945,7 +6081,7 @@
       </p:sp>
       <p:sp>
         <p:nvSpPr>
-          <p:cNvPr id="6" name="Rectangle 5"/>
+          <p:cNvPr id="7" name="Rectangle 6"/>
           <p:cNvSpPr/>
           <p:nvPr/>
         </p:nvSpPr>
@@ -5990,7 +6126,7 @@
       </p:sp>
       <p:sp>
         <p:nvSpPr>
-          <p:cNvPr id="7" name="TextBox 6"/>
+          <p:cNvPr id="8" name="TextBox 7"/>
           <p:cNvSpPr txBox="1"/>
           <p:nvPr/>
         </p:nvSpPr>
@@ -6349,7 +6485,7 @@
       </p:sp>
       <p:sp>
         <p:nvSpPr>
-          <p:cNvPr id="8" name="Rectangle 7"/>
+          <p:cNvPr id="9" name="Rectangle 8"/>
           <p:cNvSpPr/>
           <p:nvPr/>
         </p:nvSpPr>
@@ -6394,7 +6530,7 @@
       </p:sp>
       <p:sp>
         <p:nvSpPr>
-          <p:cNvPr id="9" name="TextBox 8"/>
+          <p:cNvPr id="10" name="TextBox 9"/>
           <p:cNvSpPr txBox="1"/>
           <p:nvPr/>
         </p:nvSpPr>
@@ -6839,51 +6975,32 @@
       </p:sp>
       <p:sp>
         <p:nvSpPr>
-          <p:cNvPr id="3" name="Rounded Rectangle 2"/>
-          <p:cNvSpPr/>
+          <p:cNvPr id="3" name="TextBox 2"/>
+          <p:cNvSpPr txBox="1"/>
           <p:nvPr/>
         </p:nvSpPr>
         <p:spPr>
           <a:xfrm>
-            <a:off x="3291840" y="164592"/>
-            <a:ext cx="5577840" cy="685800"/>
+            <a:off x="2286000" y="164592"/>
+            <a:ext cx="7619695" cy="685800"/>
           </a:xfrm>
-          <a:prstGeom prst="roundRect">
+          <a:prstGeom prst="rect">
             <a:avLst/>
           </a:prstGeom>
-          <a:solidFill>
-            <a:srgbClr val="FFFFFF"/>
-          </a:solidFill>
-          <a:ln w="19050">
-            <a:solidFill>
-              <a:srgbClr val="000000"/>
-            </a:solidFill>
-          </a:ln>
+          <a:noFill/>
         </p:spPr>
-        <p:style>
-          <a:lnRef idx="1">
-            <a:schemeClr val="accent1"/>
-          </a:lnRef>
-          <a:fillRef idx="3">
-            <a:schemeClr val="accent1"/>
-          </a:fillRef>
-          <a:effectRef idx="2">
-            <a:schemeClr val="accent1"/>
-          </a:effectRef>
-          <a:fontRef idx="minor">
-            <a:schemeClr val="lt1"/>
-          </a:fontRef>
-        </p:style>
-        <p:txBody>
-          <a:bodyPr rtlCol="0" anchor="ctr" wrap="square"/>
+        <p:txBody>
+          <a:bodyPr wrap="square">
+            <a:spAutoFit/>
+          </a:bodyPr>
           <a:lstStyle/>
           <a:p>
             <a:pPr algn="ctr">
-              <a:defRPr sz="2200" b="1">
-                <a:solidFill>
-                  <a:srgbClr val="000000"/>
-                </a:solidFill>
-                <a:latin typeface="Arial"/>
+              <a:defRPr sz="2600" b="1">
+                <a:solidFill>
+                  <a:srgbClr val="000000"/>
+                </a:solidFill>
+                <a:latin typeface="Times New Roman"/>
               </a:defRPr>
             </a:pPr>
             <a:r>
@@ -6918,14 +7035,67 @@
       </p:pic>
       <p:sp>
         <p:nvSpPr>
-          <p:cNvPr id="5" name="TextBox 4"/>
+          <p:cNvPr id="5" name="Rectangle 4"/>
+          <p:cNvSpPr/>
+          <p:nvPr/>
+        </p:nvSpPr>
+        <p:spPr>
+          <a:xfrm>
+            <a:off x="0" y="6510528"/>
+            <a:ext cx="12191695" cy="347472"/>
+          </a:xfrm>
+          <a:prstGeom prst="rect">
+            <a:avLst/>
+          </a:prstGeom>
+          <a:solidFill>
+            <a:srgbClr val="0070C0"/>
+          </a:solidFill>
+          <a:ln>
+            <a:noFill/>
+          </a:ln>
+        </p:spPr>
+        <p:style>
+          <a:lnRef idx="1">
+            <a:schemeClr val="accent1"/>
+          </a:lnRef>
+          <a:fillRef idx="3">
+            <a:schemeClr val="accent1"/>
+          </a:fillRef>
+          <a:effectRef idx="2">
+            <a:schemeClr val="accent1"/>
+          </a:effectRef>
+          <a:fontRef idx="minor">
+            <a:schemeClr val="lt1"/>
+          </a:fontRef>
+        </p:style>
+        <p:txBody>
+          <a:bodyPr rtlCol="0" anchor="ctr" wrap="none"/>
+          <a:lstStyle/>
+          <a:p>
+            <a:pPr algn="ctr">
+              <a:defRPr sz="1200" b="1">
+                <a:solidFill>
+                  <a:srgbClr val="FFFFFF"/>
+                </a:solidFill>
+                <a:latin typeface="Arial"/>
+              </a:defRPr>
+            </a:pPr>
+            <a:r>
+              <a:t>@SIH Idea submission- Template</a:t>
+            </a:r>
+          </a:p>
+        </p:txBody>
+      </p:sp>
+      <p:sp>
+        <p:nvSpPr>
+          <p:cNvPr id="6" name="TextBox 5"/>
           <p:cNvSpPr txBox="1"/>
           <p:nvPr/>
         </p:nvSpPr>
         <p:spPr>
           <a:xfrm>
-            <a:off x="11338560" y="6327648"/>
-            <a:ext cx="548640" cy="365760"/>
+            <a:off x="10972800" y="6510528"/>
+            <a:ext cx="1005840" cy="347472"/>
           </a:xfrm>
           <a:prstGeom prst="rect">
             <a:avLst/>
@@ -6939,9 +7109,9 @@
           <a:lstStyle/>
           <a:p>
             <a:pPr algn="r">
-              <a:defRPr sz="1400" b="1">
-                <a:solidFill>
-                  <a:srgbClr val="000000"/>
+              <a:defRPr sz="1300" b="1">
+                <a:solidFill>
+                  <a:srgbClr val="FFFFFF"/>
                 </a:solidFill>
                 <a:latin typeface="Arial"/>
               </a:defRPr>
@@ -6954,7 +7124,7 @@
       </p:sp>
       <p:sp>
         <p:nvSpPr>
-          <p:cNvPr id="6" name="Rectangle 5"/>
+          <p:cNvPr id="7" name="Rectangle 6"/>
           <p:cNvSpPr/>
           <p:nvPr/>
         </p:nvSpPr>
@@ -6999,7 +7169,7 @@
       </p:sp>
       <p:sp>
         <p:nvSpPr>
-          <p:cNvPr id="7" name="TextBox 6"/>
+          <p:cNvPr id="8" name="TextBox 7"/>
           <p:cNvSpPr txBox="1"/>
           <p:nvPr/>
         </p:nvSpPr>

</xml_diff>